<commit_message>
W04 D5 fix pass: level kept for difficulty grades only, four words glossed under the handoff line, FPP3 2.3, 2.8, 8 and 9 added to the sources
Co-Authored-By: Claude Opus 5.5 <noreply@anthropic.com>
Claude-Session: https://claude.ai/code/session_01M71s2Aai15Hcww1vRoxjrv
</commit_message>
<xml_diff>
--- a/content/W04/D5/slides/C2_W04_D05_half2_STUDENT.pptx
+++ b/content/W04/D5/slides/C2_W04_D05_half2_STUDENT.pptx
@@ -603,7 +603,12 @@
           <a:lstStyle/>
           <a:p>
             <a:r>
-              <a:t>LIVE, 2 minutes. Read the handoff line as written.</a:t>
+              <a:t>LIVE, 2 minutes. Read the handoff line as written, then point at the four words: the faculty</a:t>
+            </a:r>
+          </a:p>
+          <a:p>
+            <a:r>
+              <a:t>session defines them properly, and this table only says what each one is for.</a:t>
             </a:r>
           </a:p>
           <a:p>
@@ -5424,7 +5429,7 @@
                 </a:solidFill>
                 <a:latin typeface="Calibri"/>
               </a:rPr>
-              <a:t>What does the IITGN faculty session W4-4 (tentative) pick up from here?</a:t>
+              <a:t>What does the IITGN faculty session W4-4 pick up from here? It is tentative, and the fallback hour runs if it cannot.</a:t>
             </a:r>
           </a:p>
         </p:txBody>
@@ -5438,7 +5443,7 @@
         <p:spPr>
           <a:xfrm>
             <a:off x="530352" y="1956816"/>
-            <a:ext cx="11130991" cy="1341120"/>
+            <a:ext cx="11130991" cy="967740"/>
           </a:xfrm>
           <a:prstGeom prst="roundRect">
             <a:avLst>
@@ -5486,7 +5491,7 @@
         <p:spPr>
           <a:xfrm>
             <a:off x="676656" y="2084832"/>
-            <a:ext cx="45720" cy="1085088"/>
+            <a:ext cx="45720" cy="711708"/>
           </a:xfrm>
           <a:prstGeom prst="roundRect">
             <a:avLst>
@@ -5532,7 +5537,7 @@
         <p:spPr>
           <a:xfrm>
             <a:off x="877824" y="2075688"/>
-            <a:ext cx="10564063" cy="1158240"/>
+            <a:ext cx="10564063" cy="784860"/>
           </a:xfrm>
           <a:prstGeom prst="rect">
             <a:avLst/>
@@ -5546,7 +5551,7 @@
           <a:lstStyle/>
           <a:p>
             <a:r>
-              <a:rPr sz="1500" b="1">
+              <a:rPr sz="1300" b="1">
                 <a:solidFill>
                   <a:srgbClr val="5B3FD6"/>
                 </a:solidFill>
@@ -5555,7 +5560,7 @@
               <a:t>The handoff line. </a:t>
             </a:r>
             <a:r>
-              <a:rPr sz="1500" b="0" i="0">
+              <a:rPr sz="1300" b="0" i="0">
                 <a:solidFill>
                   <a:srgbClr val="1A1440"/>
                 </a:solidFill>
@@ -5566,45 +5571,262 @@
           </a:p>
         </p:txBody>
       </p:sp>
-      <p:sp>
-        <p:nvSpPr>
-          <p:cNvPr id="12" name="TextBox 11"/>
-          <p:cNvSpPr txBox="1"/>
-          <p:nvPr/>
-        </p:nvSpPr>
-        <p:spPr>
-          <a:xfrm>
-            <a:off x="530352" y="3462528"/>
-            <a:ext cx="11130991" cy="772160"/>
-          </a:xfrm>
-          <a:prstGeom prst="rect">
-            <a:avLst/>
-          </a:prstGeom>
-          <a:noFill/>
-        </p:spPr>
-        <p:txBody>
-          <a:bodyPr wrap="square" anchor="t" lIns="0" rIns="0" tIns="0" bIns="0">
-            <a:spAutoFit/>
-          </a:bodyPr>
-          <a:lstStyle/>
-          <a:p>
-            <a:pPr>
-              <a:spcAft>
-                <a:spcPts val="800"/>
-              </a:spcAft>
-            </a:pPr>
-            <a:r>
-              <a:rPr sz="1600" b="0" i="0">
-                <a:solidFill>
-                  <a:srgbClr val="1A1440"/>
-                </a:solidFill>
-                <a:latin typeface="Calibri"/>
-              </a:rPr>
-              <a:t>The faculty session is tentative until IIT Gandhinagar confirms it; if it does not run today, the fallback hour runs in its place.</a:t>
-            </a:r>
-          </a:p>
-        </p:txBody>
-      </p:sp>
+      <p:graphicFrame>
+        <p:nvGraphicFramePr>
+          <p:cNvPr id="12" name="Table 11"/>
+          <p:cNvGraphicFramePr>
+            <a:graphicFrameLocks noGrp="1"/>
+          </p:cNvGraphicFramePr>
+          <p:nvPr/>
+        </p:nvGraphicFramePr>
+        <p:xfrm>
+          <a:off x="530352" y="3089148"/>
+          <a:ext cx="11130991" cy="2298192"/>
+        </p:xfrm>
+        <a:graphic>
+          <a:graphicData uri="http://schemas.openxmlformats.org/drawingml/2006/table">
+            <a:tbl>
+              <a:tblPr firstRow="0" bandRow="0">
+                <a:tableStyleId>{2D5ABB26-0587-4C30-8999-92F81FD0307C}</a:tableStyleId>
+              </a:tblPr>
+              <a:tblGrid>
+                <a:gridCol w="3114997"/>
+                <a:gridCol w="8015994"/>
+              </a:tblGrid>
+              <a:tr h="335280">
+                <a:tc>
+                  <a:txBody>
+                    <a:bodyPr/>
+                    <a:lstStyle/>
+                    <a:p>
+                      <a:r>
+                        <a:rPr sz="1250" b="1" i="0">
+                          <a:solidFill>
+                            <a:srgbClr val="FFFFFF"/>
+                          </a:solidFill>
+                          <a:latin typeface="Calibri"/>
+                        </a:rPr>
+                        <a:t>The word you will hear</a:t>
+                      </a:r>
+                    </a:p>
+                  </a:txBody>
+                  <a:tcPr marL="101600" marR="101600" marT="38100" marB="38100" anchor="ctr">
+                    <a:solidFill>
+                      <a:srgbClr val="1A0F5C"/>
+                    </a:solidFill>
+                  </a:tcPr>
+                </a:tc>
+                <a:tc>
+                  <a:txBody>
+                    <a:bodyPr/>
+                    <a:lstStyle/>
+                    <a:p>
+                      <a:r>
+                        <a:rPr sz="1250" b="1" i="0">
+                          <a:solidFill>
+                            <a:srgbClr val="FFFFFF"/>
+                          </a:solidFill>
+                          <a:latin typeface="Calibri"/>
+                        </a:rPr>
+                        <a:t>What it means here</a:t>
+                      </a:r>
+                    </a:p>
+                  </a:txBody>
+                  <a:tcPr marL="101600" marR="101600" marT="38100" marB="38100" anchor="ctr">
+                    <a:solidFill>
+                      <a:srgbClr val="1A0F5C"/>
+                    </a:solidFill>
+                  </a:tcPr>
+                </a:tc>
+              </a:tr>
+              <a:tr h="542544">
+                <a:tc>
+                  <a:txBody>
+                    <a:bodyPr/>
+                    <a:lstStyle/>
+                    <a:p>
+                      <a:r>
+                        <a:rPr sz="1200" b="0" i="0">
+                          <a:solidFill>
+                            <a:srgbClr val="1A1440"/>
+                          </a:solidFill>
+                          <a:latin typeface="Calibri"/>
+                        </a:rPr>
+                        <a:t>Baseline</a:t>
+                      </a:r>
+                    </a:p>
+                  </a:txBody>
+                  <a:tcPr marL="101600" marR="101600" marT="38100" marB="38100" anchor="ctr">
+                    <a:solidFill>
+                      <a:srgbClr val="FFFFFF"/>
+                    </a:solidFill>
+                  </a:tcPr>
+                </a:tc>
+                <a:tc>
+                  <a:txBody>
+                    <a:bodyPr/>
+                    <a:lstStyle/>
+                    <a:p>
+                      <a:r>
+                        <a:rPr sz="1200" b="0" i="0">
+                          <a:solidFill>
+                            <a:srgbClr val="1A1440"/>
+                          </a:solidFill>
+                          <a:latin typeface="Calibri"/>
+                        </a:rPr>
+                        <a:t>It is the simple copy any model must beat on the hidden weeks: festival-aligned, which missed by 6,615 a week.</a:t>
+                      </a:r>
+                    </a:p>
+                  </a:txBody>
+                  <a:tcPr marL="101600" marR="101600" marT="38100" marB="38100" anchor="ctr">
+                    <a:solidFill>
+                      <a:srgbClr val="FFFFFF"/>
+                    </a:solidFill>
+                  </a:tcPr>
+                </a:tc>
+              </a:tr>
+              <a:tr h="542544">
+                <a:tc>
+                  <a:txBody>
+                    <a:bodyPr/>
+                    <a:lstStyle/>
+                    <a:p>
+                      <a:r>
+                        <a:rPr sz="1200" b="0" i="0">
+                          <a:solidFill>
+                            <a:srgbClr val="1A1440"/>
+                          </a:solidFill>
+                          <a:latin typeface="Calibri"/>
+                        </a:rPr>
+                        <a:t>Autocorrelation</a:t>
+                      </a:r>
+                    </a:p>
+                  </a:txBody>
+                  <a:tcPr marL="101600" marR="101600" marT="38100" marB="38100" anchor="ctr">
+                    <a:solidFill>
+                      <a:srgbClr val="F4F2FA"/>
+                    </a:solidFill>
+                  </a:tcPr>
+                </a:tc>
+                <a:tc>
+                  <a:txBody>
+                    <a:bodyPr/>
+                    <a:lstStyle/>
+                    <a:p>
+                      <a:r>
+                        <a:rPr sz="1200" b="0" i="0">
+                          <a:solidFill>
+                            <a:srgbClr val="1A1440"/>
+                          </a:solidFill>
+                          <a:latin typeface="Calibri"/>
+                        </a:rPr>
+                        <a:t>It measures how closely each week's shipments follow the week a fixed number of weeks earlier, one back or 52 back.</a:t>
+                      </a:r>
+                    </a:p>
+                  </a:txBody>
+                  <a:tcPr marL="101600" marR="101600" marT="38100" marB="38100" anchor="ctr">
+                    <a:solidFill>
+                      <a:srgbClr val="F4F2FA"/>
+                    </a:solidFill>
+                  </a:tcPr>
+                </a:tc>
+              </a:tr>
+              <a:tr h="335280">
+                <a:tc>
+                  <a:txBody>
+                    <a:bodyPr/>
+                    <a:lstStyle/>
+                    <a:p>
+                      <a:r>
+                        <a:rPr sz="1200" b="0" i="0">
+                          <a:solidFill>
+                            <a:srgbClr val="1A1440"/>
+                          </a:solidFill>
+                          <a:latin typeface="Calibri"/>
+                        </a:rPr>
+                        <a:t>Smoothing</a:t>
+                      </a:r>
+                    </a:p>
+                  </a:txBody>
+                  <a:tcPr marL="101600" marR="101600" marT="38100" marB="38100" anchor="ctr">
+                    <a:solidFill>
+                      <a:srgbClr val="FFFFFF"/>
+                    </a:solidFill>
+                  </a:tcPr>
+                </a:tc>
+                <a:tc>
+                  <a:txBody>
+                    <a:bodyPr/>
+                    <a:lstStyle/>
+                    <a:p>
+                      <a:r>
+                        <a:rPr sz="1200" b="0" i="0">
+                          <a:solidFill>
+                            <a:srgbClr val="1A1440"/>
+                          </a:solidFill>
+                          <a:latin typeface="Calibri"/>
+                        </a:rPr>
+                        <a:t>It forecasts from an average of past weeks that gives the most recent weeks the most weight.</a:t>
+                      </a:r>
+                    </a:p>
+                  </a:txBody>
+                  <a:tcPr marL="101600" marR="101600" marT="38100" marB="38100" anchor="ctr">
+                    <a:solidFill>
+                      <a:srgbClr val="FFFFFF"/>
+                    </a:solidFill>
+                  </a:tcPr>
+                </a:tc>
+              </a:tr>
+              <a:tr h="542544">
+                <a:tc>
+                  <a:txBody>
+                    <a:bodyPr/>
+                    <a:lstStyle/>
+                    <a:p>
+                      <a:r>
+                        <a:rPr sz="1200" b="0" i="0">
+                          <a:solidFill>
+                            <a:srgbClr val="1A1440"/>
+                          </a:solidFill>
+                          <a:latin typeface="Calibri"/>
+                        </a:rPr>
+                        <a:t>ARIMA</a:t>
+                      </a:r>
+                    </a:p>
+                  </a:txBody>
+                  <a:tcPr marL="101600" marR="101600" marT="38100" marB="38100" anchor="ctr">
+                    <a:solidFill>
+                      <a:srgbClr val="F4F2FA"/>
+                    </a:solidFill>
+                  </a:tcPr>
+                </a:tc>
+                <a:tc>
+                  <a:txBody>
+                    <a:bodyPr/>
+                    <a:lstStyle/>
+                    <a:p>
+                      <a:r>
+                        <a:rPr sz="1200" b="0" i="0">
+                          <a:solidFill>
+                            <a:srgbClr val="1A1440"/>
+                          </a:solidFill>
+                          <a:latin typeface="Calibri"/>
+                        </a:rPr>
+                        <a:t>It forecasts from the series' own past weeks and its own past misses, the pattern autocorrelation measures.</a:t>
+                      </a:r>
+                    </a:p>
+                  </a:txBody>
+                  <a:tcPr marL="101600" marR="101600" marT="38100" marB="38100" anchor="ctr">
+                    <a:solidFill>
+                      <a:srgbClr val="F4F2FA"/>
+                    </a:solidFill>
+                  </a:tcPr>
+                </a:tc>
+              </a:tr>
+            </a:tbl>
+          </a:graphicData>
+        </a:graphic>
+      </p:graphicFrame>
       <p:sp>
         <p:nvSpPr>
           <p:cNvPr id="13" name="TextBox 12"/>

</xml_diff>

<commit_message>
W04 D5: last interview round: growth flagged in transcript 2, the AI variant scored in tokens and sized to GPUs, both sides of finance's cost, averaging and per-machine costs corrected, vehicles per home in the guesstimate; the focused check recorded
Co-Authored-By: Claude Opus 5.5 <noreply@anthropic.com>
Claude-Session: https://claude.ai/code/session_01M71s2Aai15Hcww1vRoxjrv
</commit_message>
<xml_diff>
--- a/content/W04/D5/slides/C2_W04_D05_half2_STUDENT.pptx
+++ b/content/W04/D5/slides/C2_W04_D05_half2_STUDENT.pptx
@@ -716,17 +716,17 @@
           <a:lstStyle/>
           <a:p>
             <a:r>
-              <a:t>LIVE, 3 minutes. Ask the room which cost is the Rs 25 and which the Rs 5.42 here: a timed-out</a:t>
-            </a:r>
-          </a:p>
-          <a:p>
-            <a:r>
-              <a:t>request, and the idle capacity one request would have used; both are per unit of demand, as the</a:t>
-            </a:r>
-          </a:p>
-          <a:p>
-            <a:r>
-              <a:t>packer costs are per shipment. Ask what the forecast can be tested on if the feature has never launched: nothing,</a:t>
+              <a:t>LIVE, 3 minutes. Ask the room which cost is the Rs 25 and which the Rs 5.42 here: the timeouts a</a:t>
+            </a:r>
+          </a:p>
+          <a:p>
+            <a:r>
+              <a:t>GPU would prevent, and its rent for the whole booking; both are set per machine, as the packer costs</a:t>
+            </a:r>
+          </a:p>
+          <a:p>
+            <a:r>
+              <a:t>are set per shipment of a booked shift. Ask what the forecast can be tested on if the feature has never launched: nothing,</a:t>
             </a:r>
           </a:p>
           <a:p>
@@ -5139,7 +5139,7 @@
                 </a:solidFill>
                 <a:latin typeface="Calibri"/>
               </a:rPr>
-              <a:t>SHIPMENTS A WEEK, THE ERROR BAR</a:t>
+              <a:t>SHIPMENTS A WEEK, THE TYPICAL MISS</a:t>
             </a:r>
           </a:p>
         </p:txBody>
@@ -5854,7 +5854,7 @@
         <p:spPr>
           <a:xfrm>
             <a:off x="530352" y="2843784"/>
-            <a:ext cx="3588410" cy="1595120"/>
+            <a:ext cx="3588410" cy="1767840"/>
           </a:xfrm>
           <a:prstGeom prst="roundRect">
             <a:avLst>
@@ -6057,7 +6057,7 @@
         <p:spPr>
           <a:xfrm>
             <a:off x="4301642" y="2843784"/>
-            <a:ext cx="3588410" cy="1595120"/>
+            <a:ext cx="3588410" cy="1767840"/>
           </a:xfrm>
           <a:prstGeom prst="roundRect">
             <a:avLst>
@@ -6132,7 +6132,7 @@
                 </a:solidFill>
                 <a:latin typeface="Calibri"/>
               </a:rPr>
-              <a:t>The festival moves three weeks: what breaks?</a:t>
+              <a:t>Suppose the festival moves three weeks: what breaks?</a:t>
             </a:r>
           </a:p>
         </p:txBody>
@@ -6260,7 +6260,7 @@
         <p:spPr>
           <a:xfrm>
             <a:off x="8072932" y="2843784"/>
-            <a:ext cx="3588410" cy="1595120"/>
+            <a:ext cx="3588410" cy="1767840"/>
           </a:xfrm>
           <a:prstGeom prst="roundRect">
             <a:avLst>
@@ -6355,7 +6355,7 @@
         <p:spPr>
           <a:xfrm>
             <a:off x="8237524" y="3277870"/>
-            <a:ext cx="3259226" cy="862076"/>
+            <a:ext cx="3259226" cy="1027176"/>
           </a:xfrm>
           <a:prstGeom prst="rect">
             <a:avLst/>
@@ -6376,7 +6376,7 @@
                 </a:solidFill>
                 <a:latin typeface="Calibri"/>
               </a:rPr>
-              <a:t>Its margin guardrail was 2 percentage points either side of breakeven; price forecasts three to six months out missed by more, the margin swung about 12 percentage points, and Zillow wrote down about USD 304 million.</a:t>
+              <a:t>Its margin guardrail was 2 percentage points either side of breakeven; price forecasts three to six months out missed both ways by more than Zillow had modelled, the margin swung about 12 percentage points, and Zillow wrote down about USD 304 million.</a:t>
             </a:r>
           </a:p>
         </p:txBody>
@@ -6759,7 +6759,7 @@
                 </a:solidFill>
                 <a:latin typeface="Calibri"/>
               </a:rPr>
-              <a:t> is the computing a model does each time it answers a user. Size the peak from the ground up as requests open at once, with prompt and answer tokens kept apart; check it against earlier launches lined up by days from launch with the weekday kept; set capacity to the latency target with headroom. The two costs, per request, decide how much to book ahead, and a staged rollout, on-demand capacity, rate limits and a waitlist cover the rest. Written for the programme; it quotes no company's figures.</a:t>
+              <a:t> is the computing a model does each time it answers a user. Size the peak from the ground up as requests open at once, with prompt and answer tokens kept apart; check it against earlier launches lined up by days from launch with the weekday kept; set capacity to the latency target with headroom. The two costs, per machine over the booking, decide how much to book ahead, and a staged rollout, on-demand capacity, rate limits and a waitlist cover the rest. Written for the programme; it quotes no company's figures.</a:t>
             </a:r>
           </a:p>
         </p:txBody>
@@ -7971,7 +7971,7 @@
                           </a:solidFill>
                           <a:latin typeface="Calibri"/>
                         </a:rPr>
-                        <a:t>These thirteen have already picked the rule and set the cushion, so a new model is fairest judged on weeks no choice has used, such as a rolling origin through 2025's festival.</a:t>
+                        <a:t>The thirteen the handoff line names; since they also picked the rule and set the cushion, a new model that beats the baseline there is checked again on a rolling origin through 2025's festival.</a:t>
                       </a:r>
                     </a:p>
                   </a:txBody>

</xml_diff>

<commit_message>
W04 D5: date each FPP3 link, rebuild half one
Co-Authored-By: Claude Opus 5.5 <noreply@anthropic.com>
Claude-Session: https://claude.ai/code/session_01Ey99XQtchbgeMsPeBDVB4c
</commit_message>
<xml_diff>
--- a/content/W04/D5/slides/C2_W04_D05_half2_STUDENT.pptx
+++ b/content/W04/D5/slides/C2_W04_D05_half2_STUDENT.pptx
@@ -1299,7 +1299,12 @@
           </a:p>
           <a:p>
             <a:r>
-              <a:t>transcripts: the cushion read from the scored weeks, and the overtime that may cap the peak.</a:t>
+              <a:t>transcripts: the cushion read from the scored weeks, beyond the row, and the overtime that may cap</a:t>
+            </a:r>
+          </a:p>
+          <a:p>
+            <a:r>
+              <a:t>the peak.</a:t>
             </a:r>
           </a:p>
           <a:p>
@@ -2389,7 +2394,7 @@
           </a:p>
           <a:p>
             <a:r>
-              <a:t>subtopics; the fallback deck's part 4 and notebook 07's depth section carry it, so park any "how far</a:t>
+              <a:t>subtopics; the fallback deck's part 3 and notebook 07's depth section carry it, so park any "how far</a:t>
             </a:r>
           </a:p>
           <a:p>

</xml_diff>

<commit_message>
W04 D5: Friday's S4 opens the home screen; F3 and F2 move off their answer slides
Cold read findings 9, 10, 11, 14 and 15. S4's note opens the home screen,
whose Friday box lists the five topics, as the other concept maps do.
F3's stall set leaves S19 for the end of S18, before S19 shows where the
calendar copy puts the dip, and its note names the copy's reach. S46's
note drops its F3 call, and half2 S3's note opens F3's case set after
the second vote, on the slide's own letters. F2's case set leaves S50
for S57, after S56, so its board no longer answers S53 and S55 before
their votes. Notes only; both pptx files are rebuilt from the markdown,
every picture and every text box unchanged, notes changed on half1's
S4, S18, S19, S46, S50 and S57 and half2's S3 alone.

Co-Authored-By: Claude Opus 5.5 <noreply@anthropic.com>
Claude-Session: https://claude.ai/code/session_011kYMRj7tjE2hX831VwHFAB
</commit_message>
<xml_diff>
--- a/content/W04/D5/slides/C2_W04_D05_half2_STUDENT.pptx
+++ b/content/W04/D5/slides/C2_W04_D05_half2_STUDENT.pptx
@@ -1964,7 +1964,17 @@
           </a:p>
           <a:p>
             <a:r>
-              <a:t>in, and the group that notices wins the plan. Vote, argue, vote again. Explorer: scene F3.</a:t>
+              <a:t>in, and the group that notices wins the plan. Vote, argue, vote again. Explorer: scene F3 on the</a:t>
+            </a:r>
+          </a:p>
+          <a:p>
+            <a:r>
+              <a:t>case set, after the second vote; its letters and key are this slide's, so read the room's letter</a:t>
+            </a:r>
+          </a:p>
+          <a:p>
+            <a:r>
+              <a:t>into it.</a:t>
             </a:r>
           </a:p>
           <a:p>

</xml_diff>